<commit_message>
Refresh report with HubSpot + M365 data for March 10, 2026
Enriched all slides with data from both HubSpot CRM (deals, pipeline,
stages) and Microsoft 365 (Outlook emails from Diane Whitfield and
Ana Delgado).

Key M365 enrichments over HubSpot-only version:
- Marketing attribution corrected to 45% (from 11% deal-name inference)
  using Diane's internal pipeline breakdown email
- Territory split added: East 55% vs West 28% marketing-sourced
- DataVault 18% discount detail and CFO approval requirement
- Meridian competitive pricing (~25% below list) from Ana's emails
- Greenleaf 15% retention discount context
- Meridian Corp rollout pause (legal DPA review)
- Paid media budget increase $240K->$275K (LinkedIn CPCs +22%)
- Veldra Insights launch rescheduled to March 22

Co-Authored-By: Claude Opus 4.6 <noreply@anthropic.com>
Claude-Session: https://claude.ai/code/session_01UU9RQUgDjP2HkX7TcdFQQn
</commit_message>
<xml_diff>
--- a/Aethon04_PipelineReview_Mar10_2026.pptx
+++ b/Aethon04_PipelineReview_Mar10_2026.pptx
@@ -5541,7 +5541,7 @@
                 </a:solidFill>
                 <a:latin typeface="Calibri"/>
               </a:rPr>
-              <a:t>February / early March closed $757K across 8 deals — above the $600K monthly target, a strong month.</a:t>
+              <a:t>February / early March closed $757K across 8 deals — above the $600K monthly target.</a:t>
             </a:r>
           </a:p>
           <a:p>
@@ -5569,7 +5569,7 @@
                 </a:solidFill>
                 <a:latin typeface="Calibri"/>
               </a:rPr>
-              <a:t>Revenue mix: new-logo 66% ($499K); expansion / renewal 34% ($258K).</a:t>
+              <a:t>Revenue mix: new-logo 66% ($499K); expansion / renewal 34% ($258K). Greenleaf renewal ($180K) required a 15% discount to counter a Meridian Platform offer.</a:t>
             </a:r>
           </a:p>
           <a:p>
@@ -5597,7 +5597,7 @@
                 </a:solidFill>
                 <a:latin typeface="Calibri"/>
               </a:rPr>
-              <a:t>Key wins: Greenleaf renewal $180K, BrightPath Workforce Analytics $142K, Nexus Financial Enterprise $118K.</a:t>
+              <a:t>Key wins: BrightPath Workforce Analytics $142K (webinar-sourced), Nexus Financial Enterprise $118K, Meridian Corp Insights $85K.</a:t>
             </a:r>
           </a:p>
           <a:p>
@@ -6258,7 +6258,7 @@
                 </a:solidFill>
                 <a:latin typeface="Calibri"/>
               </a:rPr>
-              <a:t>Late-stage pipeline strong: $472K in Contract Sent, $655K in Decision Maker Bought-In.</a:t>
+              <a:t>Late-stage pipeline strong: $472K Contract Sent (DataVault $420K), $655K Decision Maker (Pinnacle $340K, Cascade $185K).</a:t>
             </a:r>
           </a:p>
           <a:p>
@@ -6286,7 +6286,7 @@
                 </a:solidFill>
                 <a:latin typeface="Calibri"/>
               </a:rPr>
-              <a:t>Outbound-generated enterprise deals dominate: DataVault $420K, Pinnacle $340K, Summit $285K.</a:t>
+              <a:t>Territory split: East pipeline $1.84M (55% marketing-sourced); West pipeline $1.10M (28% marketing-sourced).</a:t>
             </a:r>
           </a:p>
         </p:txBody>
@@ -6947,7 +6947,7 @@
                 </a:solidFill>
                 <a:latin typeface="Calibri"/>
               </a:rPr>
-              <a:t>DataVault Corp ($420K) is the largest commit deal — contract sent, expected close mid-April. Pinnacle Industries ($340K) has decision-maker buy-in, targeting end of April.</a:t>
+              <a:t>DataVault ($420K): 18% discount under review (3-yr commit, fintech vertical); needs CFO sign-off. Pinnacle ($340K): decision-maker bought in, targeting end of April.</a:t>
             </a:r>
           </a:p>
         </p:txBody>
@@ -7556,7 +7556,7 @@
                 </a:solidFill>
                 <a:latin typeface="Calibri"/>
               </a:rPr>
-              <a:t>Three losses to Meridian Platform (Apex Dynamics $95K, Crestview Group $72K, HarborTech $58K) — now a clear competitive pattern requiring response.</a:t>
+              <a:t>Three losses to Meridian Platform ($225K total: Apex Dynamics $95K, Crestview $72K, HarborTech $58K). Meridian is pricing ~25% below list — also used to threaten the Greenleaf renewal.</a:t>
             </a:r>
           </a:p>
         </p:txBody>
@@ -7874,7 +7874,7 @@
                 </a:solidFill>
                 <a:latin typeface="Calibri"/>
               </a:rPr>
-              <a:t>30%</a:t>
+              <a:t>45%</a:t>
             </a:r>
           </a:p>
         </p:txBody>
@@ -8137,7 +8137,7 @@
                 </a:solidFill>
                 <a:latin typeface="Calibri"/>
               </a:rPr>
-              <a:t>Marketing-sourced closed revenue was 30% in the period (BrightPath $142K, Meridian Corp $85K); open pipeline contribution lower at ~11%.</a:t>
+              <a:t>Marketing-sourced pipeline is 45% of open deals ($1.32M of $2.94M). Territory gap: East 55% vs West 28% — extending top campaigns to West is the top lever.</a:t>
             </a:r>
           </a:p>
           <a:p>
@@ -8165,7 +8165,7 @@
                 </a:solidFill>
                 <a:latin typeface="Calibri"/>
               </a:rPr>
-              <a:t>Insights Launch and Newsletter Promo campaigns generating pipeline ($371K open); Workforce Analytics Webinar delivered the BrightPath win.</a:t>
+              <a:t>Q1 Workforce Analytics Webinar is the top campaign: 8 SQLs, $840K attributed pipeline (East only). Paid media budget increased to $275K (+$35K) after LinkedIn CPCs rose 22%.</a:t>
             </a:r>
           </a:p>
         </p:txBody>
@@ -8746,7 +8746,7 @@
                 </a:solidFill>
                 <a:latin typeface="Calibri"/>
               </a:rPr>
-              <a:t>Pipeline coverage still below 3× — need continued LinkedIn spend increase and additional outbound campaigns for Q2 pipeline.</a:t>
+              <a:t>DataVault $420K pricing exception (18% discount) awaiting CFO approval — deal contingent on sign-off.</a:t>
             </a:r>
           </a:p>
           <a:p>
@@ -8774,7 +8774,7 @@
                 </a:solidFill>
                 <a:latin typeface="Calibri"/>
               </a:rPr>
-              <a:t>Meridian Platform competitive response: 3 losses in February totaling $225K — requesting competitive battle card and pricing review.</a:t>
+              <a:t>Extend Workforce Analytics Webinar to West territory — East delivers 55% marketing-sourced pipeline vs West 28%; this is the fastest path to close the gap.</a:t>
             </a:r>
           </a:p>
           <a:p>
@@ -8802,7 +8802,7 @@
                 </a:solidFill>
                 <a:latin typeface="Calibri"/>
               </a:rPr>
-              <a:t>Sales-tool evaluation: decision was due mid-February — need status update and timeline to close.</a:t>
+              <a:t>Meridian Corp ($85K) rollout paused for legal DPA review — expected 2–3 weeks; no product concerns.</a:t>
             </a:r>
           </a:p>
         </p:txBody>
@@ -9383,7 +9383,7 @@
                 </a:solidFill>
                 <a:latin typeface="Calibri"/>
               </a:rPr>
-              <a:t>Meridian Platform is now a confirmed competitive threat — 3 losses in February ($225K). Without a response plan, expect continued losses in Q2.</a:t>
+              <a:t>Meridian Platform: 3 losses ($225K) plus aggressive pricing on renewals (~25% below list). Greenleaf saved with 15% discount; expect more pricing pressure in Q2.</a:t>
             </a:r>
           </a:p>
           <a:p>
@@ -9411,7 +9411,7 @@
                 </a:solidFill>
                 <a:latin typeface="Calibri"/>
               </a:rPr>
-              <a:t>Pipeline coverage at 2.19× (improved from 1.75×) but still short of 3× target. Q2 quota attainment depends on sustained pipeline creation.</a:t>
+              <a:t>Pipeline coverage at 2.19× (up from 1.75×) but still short of 3×. West territory marketing-sourced pipeline is only 28% — over-reliance on outbound is a concentration risk.</a:t>
             </a:r>
           </a:p>
           <a:p>
@@ -9439,7 +9439,7 @@
                 </a:solidFill>
                 <a:latin typeface="Calibri"/>
               </a:rPr>
-              <a:t>Marketing-sourced pipeline share declining (30% closed, ~11% open). Over-reliance on outbound for Q2 is a concentration risk.</a:t>
+              <a:t>Veldra Insights launch rescheduled to March 22 — press-kit timeline at risk from rebrand budget reallocation. Could affect Q2 pipeline generation if delayed further.</a:t>
             </a:r>
           </a:p>
         </p:txBody>

</xml_diff>